<commit_message>
Cleaned up plates and added holes etc...
</commit_message>
<xml_diff>
--- a/CAD dimensions etc.pptx
+++ b/CAD dimensions etc.pptx
@@ -106,6 +106,11 @@
       </a:defRPr>
     </a:lvl9pPr>
   </p:defaultTextStyle>
+  <p:extLst>
+    <p:ext uri="{EFAFB233-063F-42B5-8137-9DF3F51BA10A}">
+      <p15:sldGuideLst xmlns:p15="http://schemas.microsoft.com/office/powerpoint/2012/main"/>
+    </p:ext>
+  </p:extLst>
 </p:presentation>
 </file>
 
@@ -6656,6 +6661,348 @@
           </a:p>
         </p:txBody>
       </p:sp>
+      <p:cxnSp>
+        <p:nvCxnSpPr>
+          <p:cNvPr id="3" name="Straight Arrow Connector 2">
+            <a:extLst>
+              <a:ext uri="{FF2B5EF4-FFF2-40B4-BE49-F238E27FC236}">
+                <a16:creationId xmlns:a16="http://schemas.microsoft.com/office/drawing/2014/main" id="{C4983163-B96D-4CC6-AFA2-EEB3A478D9DF}"/>
+              </a:ext>
+            </a:extLst>
+          </p:cNvPr>
+          <p:cNvCxnSpPr/>
+          <p:nvPr/>
+        </p:nvCxnSpPr>
+        <p:spPr>
+          <a:xfrm flipH="1">
+            <a:off x="7169150" y="3984625"/>
+            <a:ext cx="276225" cy="68262"/>
+          </a:xfrm>
+          <a:prstGeom prst="straightConnector1">
+            <a:avLst/>
+          </a:prstGeom>
+          <a:ln>
+            <a:tailEnd type="triangle"/>
+          </a:ln>
+        </p:spPr>
+        <p:style>
+          <a:lnRef idx="1">
+            <a:schemeClr val="accent1"/>
+          </a:lnRef>
+          <a:fillRef idx="0">
+            <a:schemeClr val="accent1"/>
+          </a:fillRef>
+          <a:effectRef idx="0">
+            <a:schemeClr val="accent1"/>
+          </a:effectRef>
+          <a:fontRef idx="minor">
+            <a:schemeClr val="tx1"/>
+          </a:fontRef>
+        </p:style>
+      </p:cxnSp>
+      <p:cxnSp>
+        <p:nvCxnSpPr>
+          <p:cNvPr id="7" name="Straight Arrow Connector 6">
+            <a:extLst>
+              <a:ext uri="{FF2B5EF4-FFF2-40B4-BE49-F238E27FC236}">
+                <a16:creationId xmlns:a16="http://schemas.microsoft.com/office/drawing/2014/main" id="{B5B53C18-621A-47F7-BC88-6CA9D49961FC}"/>
+              </a:ext>
+            </a:extLst>
+          </p:cNvPr>
+          <p:cNvCxnSpPr/>
+          <p:nvPr/>
+        </p:nvCxnSpPr>
+        <p:spPr>
+          <a:xfrm flipV="1">
+            <a:off x="7502525" y="3906025"/>
+            <a:ext cx="444770" cy="78600"/>
+          </a:xfrm>
+          <a:prstGeom prst="straightConnector1">
+            <a:avLst/>
+          </a:prstGeom>
+          <a:ln>
+            <a:tailEnd type="triangle"/>
+          </a:ln>
+        </p:spPr>
+        <p:style>
+          <a:lnRef idx="1">
+            <a:schemeClr val="accent1"/>
+          </a:lnRef>
+          <a:fillRef idx="0">
+            <a:schemeClr val="accent1"/>
+          </a:fillRef>
+          <a:effectRef idx="0">
+            <a:schemeClr val="accent1"/>
+          </a:effectRef>
+          <a:fontRef idx="minor">
+            <a:schemeClr val="tx1"/>
+          </a:fontRef>
+        </p:style>
+      </p:cxnSp>
+      <p:cxnSp>
+        <p:nvCxnSpPr>
+          <p:cNvPr id="10" name="Straight Arrow Connector 9">
+            <a:extLst>
+              <a:ext uri="{FF2B5EF4-FFF2-40B4-BE49-F238E27FC236}">
+                <a16:creationId xmlns:a16="http://schemas.microsoft.com/office/drawing/2014/main" id="{9B178320-1688-4871-9B97-218721767D0A}"/>
+              </a:ext>
+            </a:extLst>
+          </p:cNvPr>
+          <p:cNvCxnSpPr/>
+          <p:nvPr/>
+        </p:nvCxnSpPr>
+        <p:spPr>
+          <a:xfrm flipH="1">
+            <a:off x="7166768" y="4050260"/>
+            <a:ext cx="278607" cy="484059"/>
+          </a:xfrm>
+          <a:prstGeom prst="straightConnector1">
+            <a:avLst/>
+          </a:prstGeom>
+          <a:ln>
+            <a:tailEnd type="triangle"/>
+          </a:ln>
+        </p:spPr>
+        <p:style>
+          <a:lnRef idx="1">
+            <a:schemeClr val="accent1"/>
+          </a:lnRef>
+          <a:fillRef idx="0">
+            <a:schemeClr val="accent1"/>
+          </a:fillRef>
+          <a:effectRef idx="0">
+            <a:schemeClr val="accent1"/>
+          </a:effectRef>
+          <a:fontRef idx="minor">
+            <a:schemeClr val="tx1"/>
+          </a:fontRef>
+        </p:style>
+      </p:cxnSp>
+      <p:cxnSp>
+        <p:nvCxnSpPr>
+          <p:cNvPr id="13" name="Straight Arrow Connector 12">
+            <a:extLst>
+              <a:ext uri="{FF2B5EF4-FFF2-40B4-BE49-F238E27FC236}">
+                <a16:creationId xmlns:a16="http://schemas.microsoft.com/office/drawing/2014/main" id="{E4493A0B-8D36-4449-8E98-CD1B8CD159CD}"/>
+              </a:ext>
+            </a:extLst>
+          </p:cNvPr>
+          <p:cNvCxnSpPr/>
+          <p:nvPr/>
+        </p:nvCxnSpPr>
+        <p:spPr>
+          <a:xfrm>
+            <a:off x="7462188" y="4052887"/>
+            <a:ext cx="485107" cy="1081088"/>
+          </a:xfrm>
+          <a:prstGeom prst="straightConnector1">
+            <a:avLst/>
+          </a:prstGeom>
+          <a:ln>
+            <a:tailEnd type="triangle"/>
+          </a:ln>
+        </p:spPr>
+        <p:style>
+          <a:lnRef idx="1">
+            <a:schemeClr val="accent1"/>
+          </a:lnRef>
+          <a:fillRef idx="0">
+            <a:schemeClr val="accent1"/>
+          </a:fillRef>
+          <a:effectRef idx="0">
+            <a:schemeClr val="accent1"/>
+          </a:effectRef>
+          <a:fontRef idx="minor">
+            <a:schemeClr val="tx1"/>
+          </a:fontRef>
+        </p:style>
+      </p:cxnSp>
+      <p:sp>
+        <p:nvSpPr>
+          <p:cNvPr id="15" name="TextBox 14">
+            <a:extLst>
+              <a:ext uri="{FF2B5EF4-FFF2-40B4-BE49-F238E27FC236}">
+                <a16:creationId xmlns:a16="http://schemas.microsoft.com/office/drawing/2014/main" id="{584C637C-1173-4477-8879-023E3CCB02AE}"/>
+              </a:ext>
+            </a:extLst>
+          </p:cNvPr>
+          <p:cNvSpPr txBox="1"/>
+          <p:nvPr/>
+        </p:nvSpPr>
+        <p:spPr>
+          <a:xfrm>
+            <a:off x="7227372" y="3875397"/>
+            <a:ext cx="510076" cy="276999"/>
+          </a:xfrm>
+          <a:prstGeom prst="rect">
+            <a:avLst/>
+          </a:prstGeom>
+          <a:noFill/>
+        </p:spPr>
+        <p:txBody>
+          <a:bodyPr wrap="none" rtlCol="0">
+            <a:spAutoFit/>
+          </a:bodyPr>
+          <a:lstStyle/>
+          <a:p>
+            <a:r>
+              <a:rPr lang="en-US" sz="1200" dirty="0"/>
+              <a:t>3mm</a:t>
+            </a:r>
+          </a:p>
+        </p:txBody>
+      </p:sp>
+      <p:cxnSp>
+        <p:nvCxnSpPr>
+          <p:cNvPr id="20" name="Straight Arrow Connector 19">
+            <a:extLst>
+              <a:ext uri="{FF2B5EF4-FFF2-40B4-BE49-F238E27FC236}">
+                <a16:creationId xmlns:a16="http://schemas.microsoft.com/office/drawing/2014/main" id="{3883AA0A-C6CC-4432-ADC7-7F966324A574}"/>
+              </a:ext>
+            </a:extLst>
+          </p:cNvPr>
+          <p:cNvCxnSpPr/>
+          <p:nvPr/>
+        </p:nvCxnSpPr>
+        <p:spPr>
+          <a:xfrm flipH="1">
+            <a:off x="8017820" y="3541915"/>
+            <a:ext cx="507055" cy="508345"/>
+          </a:xfrm>
+          <a:prstGeom prst="straightConnector1">
+            <a:avLst/>
+          </a:prstGeom>
+          <a:ln>
+            <a:tailEnd type="triangle"/>
+          </a:ln>
+        </p:spPr>
+        <p:style>
+          <a:lnRef idx="1">
+            <a:schemeClr val="accent1"/>
+          </a:lnRef>
+          <a:fillRef idx="0">
+            <a:schemeClr val="accent1"/>
+          </a:fillRef>
+          <a:effectRef idx="0">
+            <a:schemeClr val="accent1"/>
+          </a:effectRef>
+          <a:fontRef idx="minor">
+            <a:schemeClr val="tx1"/>
+          </a:fontRef>
+        </p:style>
+      </p:cxnSp>
+      <p:sp>
+        <p:nvSpPr>
+          <p:cNvPr id="46" name="TextBox 45">
+            <a:extLst>
+              <a:ext uri="{FF2B5EF4-FFF2-40B4-BE49-F238E27FC236}">
+                <a16:creationId xmlns:a16="http://schemas.microsoft.com/office/drawing/2014/main" id="{D12C7863-2CAB-4581-8F84-D3EDE5AB581D}"/>
+              </a:ext>
+            </a:extLst>
+          </p:cNvPr>
+          <p:cNvSpPr txBox="1"/>
+          <p:nvPr/>
+        </p:nvSpPr>
+        <p:spPr>
+          <a:xfrm>
+            <a:off x="8320504" y="3325597"/>
+            <a:ext cx="510076" cy="276999"/>
+          </a:xfrm>
+          <a:prstGeom prst="rect">
+            <a:avLst/>
+          </a:prstGeom>
+          <a:noFill/>
+        </p:spPr>
+        <p:txBody>
+          <a:bodyPr wrap="none" rtlCol="0">
+            <a:spAutoFit/>
+          </a:bodyPr>
+          <a:lstStyle/>
+          <a:p>
+            <a:r>
+              <a:rPr lang="en-US" sz="1200" dirty="0"/>
+              <a:t>4mm</a:t>
+            </a:r>
+          </a:p>
+        </p:txBody>
+      </p:sp>
+      <p:sp>
+        <p:nvSpPr>
+          <p:cNvPr id="47" name="TextBox 46">
+            <a:extLst>
+              <a:ext uri="{FF2B5EF4-FFF2-40B4-BE49-F238E27FC236}">
+                <a16:creationId xmlns:a16="http://schemas.microsoft.com/office/drawing/2014/main" id="{0CC1C686-B85F-4A5F-806B-133DE2FAD53F}"/>
+              </a:ext>
+            </a:extLst>
+          </p:cNvPr>
+          <p:cNvSpPr txBox="1"/>
+          <p:nvPr/>
+        </p:nvSpPr>
+        <p:spPr>
+          <a:xfrm>
+            <a:off x="8733387" y="5428485"/>
+            <a:ext cx="510076" cy="276999"/>
+          </a:xfrm>
+          <a:prstGeom prst="rect">
+            <a:avLst/>
+          </a:prstGeom>
+          <a:noFill/>
+        </p:spPr>
+        <p:txBody>
+          <a:bodyPr wrap="none" rtlCol="0">
+            <a:spAutoFit/>
+          </a:bodyPr>
+          <a:lstStyle/>
+          <a:p>
+            <a:r>
+              <a:rPr lang="en-US" sz="1200" dirty="0"/>
+              <a:t>4mm</a:t>
+            </a:r>
+          </a:p>
+        </p:txBody>
+      </p:sp>
+      <p:cxnSp>
+        <p:nvCxnSpPr>
+          <p:cNvPr id="53" name="Straight Arrow Connector 52">
+            <a:extLst>
+              <a:ext uri="{FF2B5EF4-FFF2-40B4-BE49-F238E27FC236}">
+                <a16:creationId xmlns:a16="http://schemas.microsoft.com/office/drawing/2014/main" id="{17666686-D42A-494A-950D-3301952443CB}"/>
+              </a:ext>
+            </a:extLst>
+          </p:cNvPr>
+          <p:cNvCxnSpPr>
+            <a:cxnSpLocks/>
+            <a:stCxn id="47" idx="1"/>
+          </p:cNvCxnSpPr>
+          <p:nvPr/>
+        </p:nvCxnSpPr>
+        <p:spPr>
+          <a:xfrm flipH="1" flipV="1">
+            <a:off x="7999325" y="4956647"/>
+            <a:ext cx="734062" cy="610338"/>
+          </a:xfrm>
+          <a:prstGeom prst="straightConnector1">
+            <a:avLst/>
+          </a:prstGeom>
+          <a:ln>
+            <a:tailEnd type="triangle"/>
+          </a:ln>
+        </p:spPr>
+        <p:style>
+          <a:lnRef idx="1">
+            <a:schemeClr val="accent1"/>
+          </a:lnRef>
+          <a:fillRef idx="0">
+            <a:schemeClr val="accent1"/>
+          </a:fillRef>
+          <a:effectRef idx="0">
+            <a:schemeClr val="accent1"/>
+          </a:effectRef>
+          <a:fontRef idx="minor">
+            <a:schemeClr val="tx1"/>
+          </a:fontRef>
+        </p:style>
+      </p:cxnSp>
     </p:spTree>
     <p:extLst>
       <p:ext uri="{BB962C8B-B14F-4D97-AF65-F5344CB8AC3E}">

</xml_diff>